<commit_message>
Fix: add RF justification, clarify StandardScaler rationale, highlight threshold trade-off
</commit_message>
<xml_diff>
--- a/BigVeri_SaldiriTespiti_Sunum.pptx
+++ b/BigVeri_SaldiriTespiti_Sunum.pptx
@@ -7842,6 +7842,164 @@
                 <a:latin typeface="Calibri"/>
               </a:rPr>
               <a:t>Otomatik karar sistemleri şeffaflık, hesap verebilirlik ve açıklanabilirlik (XAI) gerektirir. Her yanlış sınıflandırma, somut bir insanı etkiler; bu nedenle model kararları açıklanabilir olmalıdır.</a:t>
+            </a:r>
+          </a:p>
+        </p:txBody>
+      </p:sp>
+      <p:sp>
+        <p:nvSpPr>
+          <p:cNvPr id="19" name="Rectangle 18"/>
+          <p:cNvSpPr/>
+          <p:nvPr/>
+        </p:nvSpPr>
+        <p:spPr>
+          <a:xfrm>
+            <a:off x="365760" y="5806440"/>
+            <a:ext cx="11460175" cy="868680"/>
+          </a:xfrm>
+          <a:prstGeom prst="rect">
+            <a:avLst/>
+          </a:prstGeom>
+          <a:solidFill>
+            <a:srgbClr val="F57F17"/>
+          </a:solidFill>
+          <a:ln>
+            <a:noFill/>
+          </a:ln>
+        </p:spPr>
+        <p:style>
+          <a:lnRef idx="1">
+            <a:schemeClr val="accent1"/>
+          </a:lnRef>
+          <a:fillRef idx="3">
+            <a:schemeClr val="accent1"/>
+          </a:fillRef>
+          <a:effectRef idx="2">
+            <a:schemeClr val="accent1"/>
+          </a:effectRef>
+          <a:fontRef idx="minor">
+            <a:schemeClr val="lt1"/>
+          </a:fontRef>
+        </p:style>
+        <p:txBody>
+          <a:bodyPr rtlCol="0" anchor="ctr"/>
+          <a:lstStyle/>
+          <a:p>
+            <a:pPr algn="ctr"/>
+          </a:p>
+        </p:txBody>
+      </p:sp>
+      <p:sp>
+        <p:nvSpPr>
+          <p:cNvPr id="20" name="Rectangle 19"/>
+          <p:cNvSpPr/>
+          <p:nvPr/>
+        </p:nvSpPr>
+        <p:spPr>
+          <a:xfrm>
+            <a:off x="384048" y="5824728"/>
+            <a:ext cx="11423599" cy="832103"/>
+          </a:xfrm>
+          <a:prstGeom prst="rect">
+            <a:avLst/>
+          </a:prstGeom>
+          <a:solidFill>
+            <a:srgbClr val="FFF9C4"/>
+          </a:solidFill>
+          <a:ln w="25400">
+            <a:solidFill>
+              <a:srgbClr val="F57F17"/>
+            </a:solidFill>
+          </a:ln>
+        </p:spPr>
+        <p:style>
+          <a:lnRef idx="1">
+            <a:schemeClr val="accent1"/>
+          </a:lnRef>
+          <a:fillRef idx="3">
+            <a:schemeClr val="accent1"/>
+          </a:fillRef>
+          <a:effectRef idx="2">
+            <a:schemeClr val="accent1"/>
+          </a:effectRef>
+          <a:fontRef idx="minor">
+            <a:schemeClr val="lt1"/>
+          </a:fontRef>
+        </p:style>
+        <p:txBody>
+          <a:bodyPr rtlCol="0" anchor="ctr"/>
+          <a:lstStyle/>
+          <a:p>
+            <a:pPr algn="ctr"/>
+          </a:p>
+        </p:txBody>
+      </p:sp>
+      <p:sp>
+        <p:nvSpPr>
+          <p:cNvPr id="21" name="TextBox 20"/>
+          <p:cNvSpPr txBox="1"/>
+          <p:nvPr/>
+        </p:nvSpPr>
+        <p:spPr>
+          <a:xfrm>
+            <a:off x="548640" y="5888736"/>
+            <a:ext cx="1828800" cy="347472"/>
+          </a:xfrm>
+          <a:prstGeom prst="rect">
+            <a:avLst/>
+          </a:prstGeom>
+          <a:noFill/>
+        </p:spPr>
+        <p:txBody>
+          <a:bodyPr wrap="square" lIns="45720" rIns="45720" tIns="27432" bIns="27432">
+            <a:spAutoFit/>
+          </a:bodyPr>
+          <a:lstStyle/>
+          <a:p>
+            <a:pPr algn="l"/>
+            <a:r>
+              <a:rPr sz="1200" b="1" i="0">
+                <a:solidFill>
+                  <a:srgbClr val="F57F17"/>
+                </a:solidFill>
+                <a:latin typeface="Calibri"/>
+              </a:rPr>
+              <a:t>TEMEL ÇIKARIM:</a:t>
+            </a:r>
+          </a:p>
+        </p:txBody>
+      </p:sp>
+      <p:sp>
+        <p:nvSpPr>
+          <p:cNvPr id="22" name="TextBox 21"/>
+          <p:cNvSpPr txBox="1"/>
+          <p:nvPr/>
+        </p:nvSpPr>
+        <p:spPr>
+          <a:xfrm>
+            <a:off x="2468880" y="5888736"/>
+            <a:ext cx="9357055" cy="685800"/>
+          </a:xfrm>
+          <a:prstGeom prst="rect">
+            <a:avLst/>
+          </a:prstGeom>
+          <a:noFill/>
+        </p:spPr>
+        <p:txBody>
+          <a:bodyPr wrap="square" lIns="45720" rIns="45720" tIns="27432" bIns="27432">
+            <a:spAutoFit/>
+          </a:bodyPr>
+          <a:lstStyle/>
+          <a:p>
+            <a:pPr algn="l"/>
+            <a:r>
+              <a:rPr sz="1100" b="0" i="1">
+                <a:solidFill>
+                  <a:srgbClr val="1A237E"/>
+                </a:solidFill>
+                <a:latin typeface="Calibri"/>
+              </a:rPr>
+              <a:t>Eşik değeri (varsayılan 0.5) sabit tutulmamalıdır. Güvenlik öncelikli ortamlarda eşik düşürülerek recall artırılır (daha az kaçan saldırı); mahremiyet öncelikli ortamlarda eşik yükseltilerek yanlış pozitif azaltılır. Bu seçim bağlama özel, bilinçli ve etik olarak gerekçelendirilmiş bir karar olmalıdır.</a:t>
             </a:r>
           </a:p>
         </p:txBody>
@@ -12732,6 +12890,652 @@
                 <a:latin typeface="Calibri"/>
               </a:rPr>
               <a:t>Metodoloji: Analiz Boru Hattı</a:t>
+            </a:r>
+          </a:p>
+        </p:txBody>
+      </p:sp>
+      <p:sp>
+        <p:nvSpPr>
+          <p:cNvPr id="31" name="Rectangle 30"/>
+          <p:cNvSpPr/>
+          <p:nvPr/>
+        </p:nvSpPr>
+        <p:spPr>
+          <a:xfrm>
+            <a:off x="3383280" y="886968"/>
+            <a:ext cx="8442655" cy="5577840"/>
+          </a:xfrm>
+          <a:prstGeom prst="rect">
+            <a:avLst/>
+          </a:prstGeom>
+          <a:solidFill>
+            <a:srgbClr val="E8EAF6"/>
+          </a:solidFill>
+          <a:ln w="12700">
+            <a:solidFill>
+              <a:srgbClr val="1A237E"/>
+            </a:solidFill>
+          </a:ln>
+        </p:spPr>
+        <p:style>
+          <a:lnRef idx="1">
+            <a:schemeClr val="accent1"/>
+          </a:lnRef>
+          <a:fillRef idx="3">
+            <a:schemeClr val="accent1"/>
+          </a:fillRef>
+          <a:effectRef idx="2">
+            <a:schemeClr val="accent1"/>
+          </a:effectRef>
+          <a:fontRef idx="minor">
+            <a:schemeClr val="lt1"/>
+          </a:fontRef>
+        </p:style>
+        <p:txBody>
+          <a:bodyPr rtlCol="0" anchor="ctr"/>
+          <a:lstStyle/>
+          <a:p>
+            <a:pPr algn="ctr"/>
+          </a:p>
+        </p:txBody>
+      </p:sp>
+      <p:sp>
+        <p:nvSpPr>
+          <p:cNvPr id="32" name="TextBox 31"/>
+          <p:cNvSpPr txBox="1"/>
+          <p:nvPr/>
+        </p:nvSpPr>
+        <p:spPr>
+          <a:xfrm>
+            <a:off x="3493008" y="996695"/>
+            <a:ext cx="8223199" cy="411480"/>
+          </a:xfrm>
+          <a:prstGeom prst="rect">
+            <a:avLst/>
+          </a:prstGeom>
+          <a:noFill/>
+        </p:spPr>
+        <p:txBody>
+          <a:bodyPr wrap="square" lIns="45720" rIns="45720" tIns="27432" bIns="27432">
+            <a:spAutoFit/>
+          </a:bodyPr>
+          <a:lstStyle/>
+          <a:p>
+            <a:pPr algn="l"/>
+            <a:r>
+              <a:rPr sz="1500" b="1" i="0">
+                <a:solidFill>
+                  <a:srgbClr val="1A237E"/>
+                </a:solidFill>
+                <a:latin typeface="Calibri"/>
+              </a:rPr>
+              <a:t>Neden Random Forest?</a:t>
+            </a:r>
+          </a:p>
+        </p:txBody>
+      </p:sp>
+      <p:sp>
+        <p:nvSpPr>
+          <p:cNvPr id="33" name="Rectangle 32"/>
+          <p:cNvSpPr/>
+          <p:nvPr/>
+        </p:nvSpPr>
+        <p:spPr>
+          <a:xfrm>
+            <a:off x="3493008" y="1481328"/>
+            <a:ext cx="8223199" cy="73152"/>
+          </a:xfrm>
+          <a:prstGeom prst="rect">
+            <a:avLst/>
+          </a:prstGeom>
+          <a:solidFill>
+            <a:srgbClr val="1565C0"/>
+          </a:solidFill>
+          <a:ln>
+            <a:noFill/>
+          </a:ln>
+        </p:spPr>
+        <p:style>
+          <a:lnRef idx="1">
+            <a:schemeClr val="accent1"/>
+          </a:lnRef>
+          <a:fillRef idx="3">
+            <a:schemeClr val="accent1"/>
+          </a:fillRef>
+          <a:effectRef idx="2">
+            <a:schemeClr val="accent1"/>
+          </a:effectRef>
+          <a:fontRef idx="minor">
+            <a:schemeClr val="lt1"/>
+          </a:fontRef>
+        </p:style>
+        <p:txBody>
+          <a:bodyPr rtlCol="0" anchor="ctr"/>
+          <a:lstStyle/>
+          <a:p>
+            <a:pPr algn="ctr"/>
+          </a:p>
+        </p:txBody>
+      </p:sp>
+      <p:sp>
+        <p:nvSpPr>
+          <p:cNvPr id="34" name="TextBox 33"/>
+          <p:cNvSpPr txBox="1"/>
+          <p:nvPr/>
+        </p:nvSpPr>
+        <p:spPr>
+          <a:xfrm>
+            <a:off x="3493008" y="1536192"/>
+            <a:ext cx="8223199" cy="274320"/>
+          </a:xfrm>
+          <a:prstGeom prst="rect">
+            <a:avLst/>
+          </a:prstGeom>
+          <a:noFill/>
+        </p:spPr>
+        <p:txBody>
+          <a:bodyPr wrap="square" lIns="45720" rIns="45720" tIns="27432" bIns="27432">
+            <a:spAutoFit/>
+          </a:bodyPr>
+          <a:lstStyle/>
+          <a:p>
+            <a:pPr algn="l"/>
+            <a:r>
+              <a:rPr sz="1200" b="1" i="0">
+                <a:solidFill>
+                  <a:srgbClr val="1565C0"/>
+                </a:solidFill>
+                <a:latin typeface="Calibri"/>
+              </a:rPr>
+              <a:t>Aşırı öğrenmeye direnç</a:t>
+            </a:r>
+          </a:p>
+        </p:txBody>
+      </p:sp>
+      <p:sp>
+        <p:nvSpPr>
+          <p:cNvPr id="35" name="TextBox 34"/>
+          <p:cNvSpPr txBox="1"/>
+          <p:nvPr/>
+        </p:nvSpPr>
+        <p:spPr>
+          <a:xfrm>
+            <a:off x="3566160" y="1801368"/>
+            <a:ext cx="8076895" cy="457200"/>
+          </a:xfrm>
+          <a:prstGeom prst="rect">
+            <a:avLst/>
+          </a:prstGeom>
+          <a:noFill/>
+        </p:spPr>
+        <p:txBody>
+          <a:bodyPr wrap="square" lIns="45720" rIns="45720" tIns="27432" bIns="27432">
+            <a:spAutoFit/>
+          </a:bodyPr>
+          <a:lstStyle/>
+          <a:p>
+            <a:pPr algn="l"/>
+            <a:r>
+              <a:rPr sz="1100" b="0" i="0">
+                <a:solidFill>
+                  <a:srgbClr val="1A237E"/>
+                </a:solidFill>
+                <a:latin typeface="Calibri"/>
+              </a:rPr>
+              <a:t>Yüzlerce ağacın oylama ortalaması alındığından tek ağaca göre çok daha kararlıdır.</a:t>
+            </a:r>
+          </a:p>
+        </p:txBody>
+      </p:sp>
+      <p:sp>
+        <p:nvSpPr>
+          <p:cNvPr id="36" name="Rectangle 35"/>
+          <p:cNvSpPr/>
+          <p:nvPr/>
+        </p:nvSpPr>
+        <p:spPr>
+          <a:xfrm>
+            <a:off x="3493008" y="2377440"/>
+            <a:ext cx="8223199" cy="73152"/>
+          </a:xfrm>
+          <a:prstGeom prst="rect">
+            <a:avLst/>
+          </a:prstGeom>
+          <a:solidFill>
+            <a:srgbClr val="1565C0"/>
+          </a:solidFill>
+          <a:ln>
+            <a:noFill/>
+          </a:ln>
+        </p:spPr>
+        <p:style>
+          <a:lnRef idx="1">
+            <a:schemeClr val="accent1"/>
+          </a:lnRef>
+          <a:fillRef idx="3">
+            <a:schemeClr val="accent1"/>
+          </a:fillRef>
+          <a:effectRef idx="2">
+            <a:schemeClr val="accent1"/>
+          </a:effectRef>
+          <a:fontRef idx="minor">
+            <a:schemeClr val="lt1"/>
+          </a:fontRef>
+        </p:style>
+        <p:txBody>
+          <a:bodyPr rtlCol="0" anchor="ctr"/>
+          <a:lstStyle/>
+          <a:p>
+            <a:pPr algn="ctr"/>
+          </a:p>
+        </p:txBody>
+      </p:sp>
+      <p:sp>
+        <p:nvSpPr>
+          <p:cNvPr id="37" name="TextBox 36"/>
+          <p:cNvSpPr txBox="1"/>
+          <p:nvPr/>
+        </p:nvSpPr>
+        <p:spPr>
+          <a:xfrm>
+            <a:off x="3493008" y="2432304"/>
+            <a:ext cx="8223199" cy="274320"/>
+          </a:xfrm>
+          <a:prstGeom prst="rect">
+            <a:avLst/>
+          </a:prstGeom>
+          <a:noFill/>
+        </p:spPr>
+        <p:txBody>
+          <a:bodyPr wrap="square" lIns="45720" rIns="45720" tIns="27432" bIns="27432">
+            <a:spAutoFit/>
+          </a:bodyPr>
+          <a:lstStyle/>
+          <a:p>
+            <a:pPr algn="l"/>
+            <a:r>
+              <a:rPr sz="1200" b="1" i="0">
+                <a:solidFill>
+                  <a:srgbClr val="1565C0"/>
+                </a:solidFill>
+                <a:latin typeface="Calibri"/>
+              </a:rPr>
+              <a:t>Dağılım varsayımı yok</a:t>
+            </a:r>
+          </a:p>
+        </p:txBody>
+      </p:sp>
+      <p:sp>
+        <p:nvSpPr>
+          <p:cNvPr id="38" name="TextBox 37"/>
+          <p:cNvSpPr txBox="1"/>
+          <p:nvPr/>
+        </p:nvSpPr>
+        <p:spPr>
+          <a:xfrm>
+            <a:off x="3566160" y="2697480"/>
+            <a:ext cx="8076895" cy="457200"/>
+          </a:xfrm>
+          <a:prstGeom prst="rect">
+            <a:avLst/>
+          </a:prstGeom>
+          <a:noFill/>
+        </p:spPr>
+        <p:txBody>
+          <a:bodyPr wrap="square" lIns="45720" rIns="45720" tIns="27432" bIns="27432">
+            <a:spAutoFit/>
+          </a:bodyPr>
+          <a:lstStyle/>
+          <a:p>
+            <a:pPr algn="l"/>
+            <a:r>
+              <a:rPr sz="1100" b="0" i="0">
+                <a:solidFill>
+                  <a:srgbClr val="1A237E"/>
+                </a:solidFill>
+                <a:latin typeface="Calibri"/>
+              </a:rPr>
+              <a:t>Lojistik regresyon gibi özellik dağılımı varsayımına ihtiyaç duymaz.</a:t>
+            </a:r>
+          </a:p>
+        </p:txBody>
+      </p:sp>
+      <p:sp>
+        <p:nvSpPr>
+          <p:cNvPr id="39" name="Rectangle 38"/>
+          <p:cNvSpPr/>
+          <p:nvPr/>
+        </p:nvSpPr>
+        <p:spPr>
+          <a:xfrm>
+            <a:off x="3493008" y="3273552"/>
+            <a:ext cx="8223199" cy="73152"/>
+          </a:xfrm>
+          <a:prstGeom prst="rect">
+            <a:avLst/>
+          </a:prstGeom>
+          <a:solidFill>
+            <a:srgbClr val="1565C0"/>
+          </a:solidFill>
+          <a:ln>
+            <a:noFill/>
+          </a:ln>
+        </p:spPr>
+        <p:style>
+          <a:lnRef idx="1">
+            <a:schemeClr val="accent1"/>
+          </a:lnRef>
+          <a:fillRef idx="3">
+            <a:schemeClr val="accent1"/>
+          </a:fillRef>
+          <a:effectRef idx="2">
+            <a:schemeClr val="accent1"/>
+          </a:effectRef>
+          <a:fontRef idx="minor">
+            <a:schemeClr val="lt1"/>
+          </a:fontRef>
+        </p:style>
+        <p:txBody>
+          <a:bodyPr rtlCol="0" anchor="ctr"/>
+          <a:lstStyle/>
+          <a:p>
+            <a:pPr algn="ctr"/>
+          </a:p>
+        </p:txBody>
+      </p:sp>
+      <p:sp>
+        <p:nvSpPr>
+          <p:cNvPr id="40" name="TextBox 39"/>
+          <p:cNvSpPr txBox="1"/>
+          <p:nvPr/>
+        </p:nvSpPr>
+        <p:spPr>
+          <a:xfrm>
+            <a:off x="3493008" y="3328416"/>
+            <a:ext cx="8223199" cy="274320"/>
+          </a:xfrm>
+          <a:prstGeom prst="rect">
+            <a:avLst/>
+          </a:prstGeom>
+          <a:noFill/>
+        </p:spPr>
+        <p:txBody>
+          <a:bodyPr wrap="square" lIns="45720" rIns="45720" tIns="27432" bIns="27432">
+            <a:spAutoFit/>
+          </a:bodyPr>
+          <a:lstStyle/>
+          <a:p>
+            <a:pPr algn="l"/>
+            <a:r>
+              <a:rPr sz="1200" b="1" i="0">
+                <a:solidFill>
+                  <a:srgbClr val="1565C0"/>
+                </a:solidFill>
+                <a:latin typeface="Calibri"/>
+              </a:rPr>
+              <a:t>Karma özellik tipleri</a:t>
+            </a:r>
+          </a:p>
+        </p:txBody>
+      </p:sp>
+      <p:sp>
+        <p:nvSpPr>
+          <p:cNvPr id="41" name="TextBox 40"/>
+          <p:cNvSpPr txBox="1"/>
+          <p:nvPr/>
+        </p:nvSpPr>
+        <p:spPr>
+          <a:xfrm>
+            <a:off x="3566160" y="3593592"/>
+            <a:ext cx="8076895" cy="457200"/>
+          </a:xfrm>
+          <a:prstGeom prst="rect">
+            <a:avLst/>
+          </a:prstGeom>
+          <a:noFill/>
+        </p:spPr>
+        <p:txBody>
+          <a:bodyPr wrap="square" lIns="45720" rIns="45720" tIns="27432" bIns="27432">
+            <a:spAutoFit/>
+          </a:bodyPr>
+          <a:lstStyle/>
+          <a:p>
+            <a:pPr algn="l"/>
+            <a:r>
+              <a:rPr sz="1100" b="0" i="0">
+                <a:solidFill>
+                  <a:srgbClr val="1A237E"/>
+                </a:solidFill>
+                <a:latin typeface="Calibri"/>
+              </a:rPr>
+              <a:t>Sayısal + kodlanmış kategorik özellikleri aynı anda işleyebilir.</a:t>
+            </a:r>
+          </a:p>
+        </p:txBody>
+      </p:sp>
+      <p:sp>
+        <p:nvSpPr>
+          <p:cNvPr id="42" name="Rectangle 41"/>
+          <p:cNvSpPr/>
+          <p:nvPr/>
+        </p:nvSpPr>
+        <p:spPr>
+          <a:xfrm>
+            <a:off x="3493008" y="4169664"/>
+            <a:ext cx="8223199" cy="73152"/>
+          </a:xfrm>
+          <a:prstGeom prst="rect">
+            <a:avLst/>
+          </a:prstGeom>
+          <a:solidFill>
+            <a:srgbClr val="1565C0"/>
+          </a:solidFill>
+          <a:ln>
+            <a:noFill/>
+          </a:ln>
+        </p:spPr>
+        <p:style>
+          <a:lnRef idx="1">
+            <a:schemeClr val="accent1"/>
+          </a:lnRef>
+          <a:fillRef idx="3">
+            <a:schemeClr val="accent1"/>
+          </a:fillRef>
+          <a:effectRef idx="2">
+            <a:schemeClr val="accent1"/>
+          </a:effectRef>
+          <a:fontRef idx="minor">
+            <a:schemeClr val="lt1"/>
+          </a:fontRef>
+        </p:style>
+        <p:txBody>
+          <a:bodyPr rtlCol="0" anchor="ctr"/>
+          <a:lstStyle/>
+          <a:p>
+            <a:pPr algn="ctr"/>
+          </a:p>
+        </p:txBody>
+      </p:sp>
+      <p:sp>
+        <p:nvSpPr>
+          <p:cNvPr id="43" name="TextBox 42"/>
+          <p:cNvSpPr txBox="1"/>
+          <p:nvPr/>
+        </p:nvSpPr>
+        <p:spPr>
+          <a:xfrm>
+            <a:off x="3493008" y="4224528"/>
+            <a:ext cx="8223199" cy="274320"/>
+          </a:xfrm>
+          <a:prstGeom prst="rect">
+            <a:avLst/>
+          </a:prstGeom>
+          <a:noFill/>
+        </p:spPr>
+        <p:txBody>
+          <a:bodyPr wrap="square" lIns="45720" rIns="45720" tIns="27432" bIns="27432">
+            <a:spAutoFit/>
+          </a:bodyPr>
+          <a:lstStyle/>
+          <a:p>
+            <a:pPr algn="l"/>
+            <a:r>
+              <a:rPr sz="1200" b="1" i="0">
+                <a:solidFill>
+                  <a:srgbClr val="1565C0"/>
+                </a:solidFill>
+                <a:latin typeface="Calibri"/>
+              </a:rPr>
+              <a:t>Yorumlanabilirlik</a:t>
+            </a:r>
+          </a:p>
+        </p:txBody>
+      </p:sp>
+      <p:sp>
+        <p:nvSpPr>
+          <p:cNvPr id="44" name="TextBox 43"/>
+          <p:cNvSpPr txBox="1"/>
+          <p:nvPr/>
+        </p:nvSpPr>
+        <p:spPr>
+          <a:xfrm>
+            <a:off x="3566160" y="4489704"/>
+            <a:ext cx="8076895" cy="457200"/>
+          </a:xfrm>
+          <a:prstGeom prst="rect">
+            <a:avLst/>
+          </a:prstGeom>
+          <a:noFill/>
+        </p:spPr>
+        <p:txBody>
+          <a:bodyPr wrap="square" lIns="45720" rIns="45720" tIns="27432" bIns="27432">
+            <a:spAutoFit/>
+          </a:bodyPr>
+          <a:lstStyle/>
+          <a:p>
+            <a:pPr algn="l"/>
+            <a:r>
+              <a:rPr sz="1100" b="0" i="0">
+                <a:solidFill>
+                  <a:srgbClr val="1A237E"/>
+                </a:solidFill>
+                <a:latin typeface="Calibri"/>
+              </a:rPr>
+              <a:t>Feature importance skoru sayesinde hangi özelliğin ne kadar katkı verdiği ölçülür.</a:t>
+            </a:r>
+          </a:p>
+        </p:txBody>
+      </p:sp>
+      <p:sp>
+        <p:nvSpPr>
+          <p:cNvPr id="45" name="Rectangle 44"/>
+          <p:cNvSpPr/>
+          <p:nvPr/>
+        </p:nvSpPr>
+        <p:spPr>
+          <a:xfrm>
+            <a:off x="3493008" y="5065776"/>
+            <a:ext cx="8223199" cy="73152"/>
+          </a:xfrm>
+          <a:prstGeom prst="rect">
+            <a:avLst/>
+          </a:prstGeom>
+          <a:solidFill>
+            <a:srgbClr val="1565C0"/>
+          </a:solidFill>
+          <a:ln>
+            <a:noFill/>
+          </a:ln>
+        </p:spPr>
+        <p:style>
+          <a:lnRef idx="1">
+            <a:schemeClr val="accent1"/>
+          </a:lnRef>
+          <a:fillRef idx="3">
+            <a:schemeClr val="accent1"/>
+          </a:fillRef>
+          <a:effectRef idx="2">
+            <a:schemeClr val="accent1"/>
+          </a:effectRef>
+          <a:fontRef idx="minor">
+            <a:schemeClr val="lt1"/>
+          </a:fontRef>
+        </p:style>
+        <p:txBody>
+          <a:bodyPr rtlCol="0" anchor="ctr"/>
+          <a:lstStyle/>
+          <a:p>
+            <a:pPr algn="ctr"/>
+          </a:p>
+        </p:txBody>
+      </p:sp>
+      <p:sp>
+        <p:nvSpPr>
+          <p:cNvPr id="46" name="TextBox 45"/>
+          <p:cNvSpPr txBox="1"/>
+          <p:nvPr/>
+        </p:nvSpPr>
+        <p:spPr>
+          <a:xfrm>
+            <a:off x="3493008" y="5120640"/>
+            <a:ext cx="8223199" cy="274320"/>
+          </a:xfrm>
+          <a:prstGeom prst="rect">
+            <a:avLst/>
+          </a:prstGeom>
+          <a:noFill/>
+        </p:spPr>
+        <p:txBody>
+          <a:bodyPr wrap="square" lIns="45720" rIns="45720" tIns="27432" bIns="27432">
+            <a:spAutoFit/>
+          </a:bodyPr>
+          <a:lstStyle/>
+          <a:p>
+            <a:pPr algn="l"/>
+            <a:r>
+              <a:rPr sz="1200" b="1" i="0">
+                <a:solidFill>
+                  <a:srgbClr val="1565C0"/>
+                </a:solidFill>
+                <a:latin typeface="Calibri"/>
+              </a:rPr>
+              <a:t>StandardScaler notu</a:t>
+            </a:r>
+          </a:p>
+        </p:txBody>
+      </p:sp>
+      <p:sp>
+        <p:nvSpPr>
+          <p:cNvPr id="47" name="TextBox 46"/>
+          <p:cNvSpPr txBox="1"/>
+          <p:nvPr/>
+        </p:nvSpPr>
+        <p:spPr>
+          <a:xfrm>
+            <a:off x="3566160" y="5385816"/>
+            <a:ext cx="8076895" cy="457200"/>
+          </a:xfrm>
+          <a:prstGeom prst="rect">
+            <a:avLst/>
+          </a:prstGeom>
+          <a:noFill/>
+        </p:spPr>
+        <p:txBody>
+          <a:bodyPr wrap="square" lIns="45720" rIns="45720" tIns="27432" bIns="27432">
+            <a:spAutoFit/>
+          </a:bodyPr>
+          <a:lstStyle/>
+          <a:p>
+            <a:pPr algn="l"/>
+            <a:r>
+              <a:rPr sz="1100" b="0" i="0">
+                <a:solidFill>
+                  <a:srgbClr val="1A237E"/>
+                </a:solidFill>
+                <a:latin typeface="Calibri"/>
+              </a:rPr>
+              <a:t>RF ölçeğe duyarsızdır; scaler pipeline standardizasyonu
+için eklenmiştir, modelin zorunluluğundan değil.</a:t>
             </a:r>
           </a:p>
         </p:txBody>

</xml_diff>